<commit_message>
Update Gardener Architecture Diagram
The following changes were made:
- The cluster ingress is always handled by istio ingress gateway. This
  applies to both virtual garden cluster as well as seed cluster.
- Gardenlet communicates with the seed cluster api server.
- The control plane components communicate with the api server.
- The data plane metrics are collected via the api server.
- The logging data is transferred via the istio ingress gateway to the
  logging component.

Signed-off-by: Johannes Scheerer <johannes.scheerer@sap.com>
</commit_message>
<xml_diff>
--- a/docs/concepts/images/gardener-architecture-detailed.pptx
+++ b/docs/concepts/images/gardener-architecture-detailed.pptx
@@ -197,7 +197,7 @@
           <a:p>
             <a:fld id="{13E0A233-D006-1049-96B2-56CCC883D470}" type="datetimeFigureOut">
               <a:rPr lang="en-DE" smtClean="0"/>
-              <a:t>20.09.22</a:t>
+              <a:t>10.09.26</a:t>
             </a:fld>
             <a:endParaRPr lang="en-DE"/>
           </a:p>
@@ -698,7 +698,7 @@
           <a:p>
             <a:fld id="{34148265-B100-ED48-B1D9-7B0C2D8678E5}" type="datetimeFigureOut">
               <a:rPr lang="en-DE" smtClean="0"/>
-              <a:t>20.09.22</a:t>
+              <a:t>10.09.26</a:t>
             </a:fld>
             <a:endParaRPr lang="en-DE"/>
           </a:p>
@@ -898,7 +898,7 @@
           <a:p>
             <a:fld id="{34148265-B100-ED48-B1D9-7B0C2D8678E5}" type="datetimeFigureOut">
               <a:rPr lang="en-DE" smtClean="0"/>
-              <a:t>20.09.22</a:t>
+              <a:t>10.09.26</a:t>
             </a:fld>
             <a:endParaRPr lang="en-DE"/>
           </a:p>
@@ -1108,7 +1108,7 @@
           <a:p>
             <a:fld id="{34148265-B100-ED48-B1D9-7B0C2D8678E5}" type="datetimeFigureOut">
               <a:rPr lang="en-DE" smtClean="0"/>
-              <a:t>20.09.22</a:t>
+              <a:t>10.09.26</a:t>
             </a:fld>
             <a:endParaRPr lang="en-DE"/>
           </a:p>
@@ -1308,7 +1308,7 @@
           <a:p>
             <a:fld id="{34148265-B100-ED48-B1D9-7B0C2D8678E5}" type="datetimeFigureOut">
               <a:rPr lang="en-DE" smtClean="0"/>
-              <a:t>20.09.22</a:t>
+              <a:t>10.09.26</a:t>
             </a:fld>
             <a:endParaRPr lang="en-DE"/>
           </a:p>
@@ -1584,7 +1584,7 @@
           <a:p>
             <a:fld id="{34148265-B100-ED48-B1D9-7B0C2D8678E5}" type="datetimeFigureOut">
               <a:rPr lang="en-DE" smtClean="0"/>
-              <a:t>20.09.22</a:t>
+              <a:t>10.09.26</a:t>
             </a:fld>
             <a:endParaRPr lang="en-DE"/>
           </a:p>
@@ -1852,7 +1852,7 @@
           <a:p>
             <a:fld id="{34148265-B100-ED48-B1D9-7B0C2D8678E5}" type="datetimeFigureOut">
               <a:rPr lang="en-DE" smtClean="0"/>
-              <a:t>20.09.22</a:t>
+              <a:t>10.09.26</a:t>
             </a:fld>
             <a:endParaRPr lang="en-DE"/>
           </a:p>
@@ -2267,7 +2267,7 @@
           <a:p>
             <a:fld id="{34148265-B100-ED48-B1D9-7B0C2D8678E5}" type="datetimeFigureOut">
               <a:rPr lang="en-DE" smtClean="0"/>
-              <a:t>20.09.22</a:t>
+              <a:t>10.09.26</a:t>
             </a:fld>
             <a:endParaRPr lang="en-DE"/>
           </a:p>
@@ -2409,7 +2409,7 @@
           <a:p>
             <a:fld id="{34148265-B100-ED48-B1D9-7B0C2D8678E5}" type="datetimeFigureOut">
               <a:rPr lang="en-DE" smtClean="0"/>
-              <a:t>20.09.22</a:t>
+              <a:t>10.09.26</a:t>
             </a:fld>
             <a:endParaRPr lang="en-DE"/>
           </a:p>
@@ -2522,7 +2522,7 @@
           <a:p>
             <a:fld id="{34148265-B100-ED48-B1D9-7B0C2D8678E5}" type="datetimeFigureOut">
               <a:rPr lang="en-DE" smtClean="0"/>
-              <a:t>20.09.22</a:t>
+              <a:t>10.09.26</a:t>
             </a:fld>
             <a:endParaRPr lang="en-DE"/>
           </a:p>
@@ -2835,7 +2835,7 @@
           <a:p>
             <a:fld id="{34148265-B100-ED48-B1D9-7B0C2D8678E5}" type="datetimeFigureOut">
               <a:rPr lang="en-DE" smtClean="0"/>
-              <a:t>20.09.22</a:t>
+              <a:t>10.09.26</a:t>
             </a:fld>
             <a:endParaRPr lang="en-DE"/>
           </a:p>
@@ -3124,7 +3124,7 @@
           <a:p>
             <a:fld id="{34148265-B100-ED48-B1D9-7B0C2D8678E5}" type="datetimeFigureOut">
               <a:rPr lang="en-DE" smtClean="0"/>
-              <a:t>20.09.22</a:t>
+              <a:t>10.09.26</a:t>
             </a:fld>
             <a:endParaRPr lang="en-DE"/>
           </a:p>
@@ -3367,7 +3367,7 @@
           <a:p>
             <a:fld id="{34148265-B100-ED48-B1D9-7B0C2D8678E5}" type="datetimeFigureOut">
               <a:rPr lang="en-DE" smtClean="0"/>
-              <a:t>20.09.22</a:t>
+              <a:t>10.09.26</a:t>
             </a:fld>
             <a:endParaRPr lang="en-DE"/>
           </a:p>
@@ -4775,7 +4775,7 @@
           <a:p>
             <a:pPr algn="ctr"/>
             <a:r>
-              <a:rPr lang="en-US" sz="1200"/>
+              <a:rPr lang="en-US" sz="1200" dirty="0"/>
               <a:t>Seed Cluster API LB</a:t>
             </a:r>
           </a:p>
@@ -5115,7 +5115,7 @@
       </p:sp>
       <p:sp>
         <p:nvSpPr>
-          <p:cNvPr id="211" name="Rectangle 138"/>
+          <p:cNvPr id="212" name="Rectangle 138"/>
           <p:cNvSpPr>
             <a:spLocks noChangeArrowheads="1"/>
           </p:cNvSpPr>
@@ -5123,8 +5123,8 @@
         </p:nvSpPr>
         <p:spPr bwMode="auto">
           <a:xfrm>
-            <a:off x="2744949" y="2208506"/>
-            <a:ext cx="1238961" cy="206532"/>
+            <a:off x="1088006" y="2208506"/>
+            <a:ext cx="2887198" cy="206532"/>
           </a:xfrm>
           <a:prstGeom prst="rect">
             <a:avLst/>
@@ -5151,50 +5151,7 @@
             <a:pPr algn="ctr"/>
             <a:r>
               <a:rPr lang="en-US" sz="1200" dirty="0"/>
-              <a:t>Ingress LB</a:t>
-            </a:r>
-          </a:p>
-        </p:txBody>
-      </p:sp>
-      <p:sp>
-        <p:nvSpPr>
-          <p:cNvPr id="212" name="Rectangle 138"/>
-          <p:cNvSpPr>
-            <a:spLocks noChangeArrowheads="1"/>
-          </p:cNvSpPr>
-          <p:nvPr/>
-        </p:nvSpPr>
-        <p:spPr bwMode="auto">
-          <a:xfrm>
-            <a:off x="1088006" y="2208506"/>
-            <a:ext cx="1504397" cy="206532"/>
-          </a:xfrm>
-          <a:prstGeom prst="rect">
-            <a:avLst/>
-          </a:prstGeom>
-          <a:solidFill>
-            <a:schemeClr val="accent6">
-              <a:lumMod val="40000"/>
-              <a:lumOff val="60000"/>
-            </a:schemeClr>
-          </a:solidFill>
-          <a:ln w="17780">
-            <a:solidFill>
-              <a:schemeClr val="tx1"/>
-            </a:solidFill>
-            <a:miter lim="800000"/>
-            <a:headEnd/>
-            <a:tailEnd/>
-          </a:ln>
-        </p:spPr>
-        <p:txBody>
-          <a:bodyPr lIns="36000" tIns="36000" rIns="36000" bIns="36000" anchor="ctr"/>
-          <a:lstStyle/>
-          <a:p>
-            <a:pPr algn="ctr"/>
-            <a:r>
-              <a:rPr lang="en-US" sz="1200"/>
-              <a:t>Garden Cluster API LB</a:t>
+              <a:t>Virtual Garden Istio Ingress Gateway LB</a:t>
             </a:r>
           </a:p>
         </p:txBody>
@@ -7585,7 +7542,7 @@
         </p:nvGrpSpPr>
         <p:grpSpPr>
           <a:xfrm>
-            <a:off x="-325890" y="6590078"/>
+            <a:off x="7594740" y="5918979"/>
             <a:ext cx="161055" cy="189811"/>
             <a:chOff x="6020928" y="505632"/>
             <a:chExt cx="161055" cy="189811"/>
@@ -14588,12 +14545,12 @@
         </p:nvCxnSpPr>
         <p:spPr>
           <a:xfrm rot="10800000">
-            <a:off x="5722477" y="3010255"/>
-            <a:ext cx="1101677" cy="125432"/>
+            <a:off x="5724209" y="3006932"/>
+            <a:ext cx="1451318" cy="119904"/>
           </a:xfrm>
           <a:prstGeom prst="bentConnector3">
             <a:avLst>
-              <a:gd name="adj1" fmla="val 101876"/>
+              <a:gd name="adj1" fmla="val 100146"/>
             </a:avLst>
           </a:prstGeom>
           <a:ln w="12700">
@@ -14968,7 +14925,7 @@
                 <a:buNone/>
               </a:pPr>
               <a:r>
-                <a:rPr lang="en-US" sz="800" b="1"/>
+                <a:rPr lang="en-US" sz="800" b="1" dirty="0"/>
                 <a:t>R</a:t>
               </a:r>
             </a:p>
@@ -15071,7 +15028,7 @@
         </p:nvGrpSpPr>
         <p:grpSpPr>
           <a:xfrm>
-            <a:off x="7527636" y="6030736"/>
+            <a:off x="7527636" y="5204629"/>
             <a:ext cx="180269" cy="171451"/>
             <a:chOff x="5145186" y="193240"/>
             <a:chExt cx="180269" cy="171451"/>
@@ -16005,49 +15962,6 @@
           </p:txBody>
         </p:sp>
       </p:grpSp>
-      <p:sp>
-        <p:nvSpPr>
-          <p:cNvPr id="537" name="Rectangle 138"/>
-          <p:cNvSpPr>
-            <a:spLocks noChangeArrowheads="1"/>
-          </p:cNvSpPr>
-          <p:nvPr/>
-        </p:nvSpPr>
-        <p:spPr bwMode="auto">
-          <a:xfrm>
-            <a:off x="6192367" y="2208506"/>
-            <a:ext cx="1596283" cy="206532"/>
-          </a:xfrm>
-          <a:prstGeom prst="rect">
-            <a:avLst/>
-          </a:prstGeom>
-          <a:solidFill>
-            <a:schemeClr val="accent5">
-              <a:lumMod val="40000"/>
-              <a:lumOff val="60000"/>
-            </a:schemeClr>
-          </a:solidFill>
-          <a:ln w="17780">
-            <a:solidFill>
-              <a:schemeClr val="tx1"/>
-            </a:solidFill>
-            <a:miter lim="800000"/>
-            <a:headEnd/>
-            <a:tailEnd/>
-          </a:ln>
-        </p:spPr>
-        <p:txBody>
-          <a:bodyPr lIns="36000" tIns="36000" rIns="36000" bIns="36000" anchor="ctr"/>
-          <a:lstStyle/>
-          <a:p>
-            <a:pPr algn="ctr"/>
-            <a:r>
-              <a:rPr lang="en-US" sz="1200" dirty="0"/>
-              <a:t>Istio Ingress Gateway LB</a:t>
-            </a:r>
-          </a:p>
-        </p:txBody>
-      </p:sp>
       <p:grpSp>
         <p:nvGrpSpPr>
           <p:cNvPr id="397" name="Group 396">
@@ -16939,18 +16853,18 @@
           </p:cNvPr>
           <p:cNvCxnSpPr>
             <a:cxnSpLocks/>
+            <a:stCxn id="495" idx="6"/>
+            <a:endCxn id="464" idx="3"/>
           </p:cNvCxnSpPr>
           <p:nvPr/>
         </p:nvCxnSpPr>
         <p:spPr>
-          <a:xfrm>
-            <a:off x="6614752" y="4902915"/>
-            <a:ext cx="573" cy="931501"/>
-          </a:xfrm>
-          <a:prstGeom prst="bentConnector3">
-            <a:avLst>
-              <a:gd name="adj1" fmla="val 39995288"/>
-            </a:avLst>
+          <a:xfrm rot="5400000">
+            <a:off x="6647515" y="5295816"/>
+            <a:ext cx="537621" cy="603146"/>
+          </a:xfrm>
+          <a:prstGeom prst="bentConnector2">
+            <a:avLst/>
           </a:prstGeom>
           <a:ln w="12700">
             <a:solidFill>
@@ -17139,7 +17053,7 @@
         </p:nvGrpSpPr>
         <p:grpSpPr>
           <a:xfrm>
-            <a:off x="6808680" y="5669421"/>
+            <a:off x="7181898" y="5214784"/>
             <a:ext cx="180269" cy="171029"/>
             <a:chOff x="5145186" y="581648"/>
             <a:chExt cx="180269" cy="171029"/>
@@ -18176,6 +18090,564 @@
           </a:p>
         </p:txBody>
       </p:sp>
+      <p:sp>
+        <p:nvSpPr>
+          <p:cNvPr id="537" name="Rectangle 138"/>
+          <p:cNvSpPr>
+            <a:spLocks noChangeArrowheads="1"/>
+          </p:cNvSpPr>
+          <p:nvPr/>
+        </p:nvSpPr>
+        <p:spPr bwMode="auto">
+          <a:xfrm>
+            <a:off x="6192367" y="2208506"/>
+            <a:ext cx="1596283" cy="206532"/>
+          </a:xfrm>
+          <a:prstGeom prst="rect">
+            <a:avLst/>
+          </a:prstGeom>
+          <a:solidFill>
+            <a:schemeClr val="accent5">
+              <a:lumMod val="40000"/>
+              <a:lumOff val="60000"/>
+            </a:schemeClr>
+          </a:solidFill>
+          <a:ln w="17780">
+            <a:solidFill>
+              <a:schemeClr val="tx1"/>
+            </a:solidFill>
+            <a:miter lim="800000"/>
+            <a:headEnd/>
+            <a:tailEnd/>
+          </a:ln>
+        </p:spPr>
+        <p:txBody>
+          <a:bodyPr lIns="36000" tIns="36000" rIns="36000" bIns="36000" anchor="ctr"/>
+          <a:lstStyle/>
+          <a:p>
+            <a:pPr algn="ctr"/>
+            <a:r>
+              <a:rPr lang="en-US" sz="1200" dirty="0"/>
+              <a:t>Istio Ingress Gateway LB</a:t>
+            </a:r>
+          </a:p>
+        </p:txBody>
+      </p:sp>
+      <p:cxnSp>
+        <p:nvCxnSpPr>
+          <p:cNvPr id="35" name="Elbow Connector 34">
+            <a:extLst>
+              <a:ext uri="{FF2B5EF4-FFF2-40B4-BE49-F238E27FC236}">
+                <a16:creationId xmlns:a16="http://schemas.microsoft.com/office/drawing/2014/main" id="{68526CB4-62BB-B754-1989-61490BADA2D0}"/>
+              </a:ext>
+            </a:extLst>
+          </p:cNvPr>
+          <p:cNvCxnSpPr>
+            <a:cxnSpLocks/>
+            <a:endCxn id="494" idx="3"/>
+          </p:cNvCxnSpPr>
+          <p:nvPr/>
+        </p:nvCxnSpPr>
+        <p:spPr>
+          <a:xfrm rot="5400000">
+            <a:off x="6728207" y="3431114"/>
+            <a:ext cx="753296" cy="133495"/>
+          </a:xfrm>
+          <a:prstGeom prst="bentConnector2">
+            <a:avLst/>
+          </a:prstGeom>
+          <a:ln w="12700">
+            <a:solidFill>
+              <a:schemeClr val="tx1"/>
+            </a:solidFill>
+          </a:ln>
+        </p:spPr>
+        <p:style>
+          <a:lnRef idx="1">
+            <a:schemeClr val="accent1"/>
+          </a:lnRef>
+          <a:fillRef idx="0">
+            <a:schemeClr val="accent1"/>
+          </a:fillRef>
+          <a:effectRef idx="0">
+            <a:schemeClr val="accent1"/>
+          </a:effectRef>
+          <a:fontRef idx="minor">
+            <a:schemeClr val="tx1"/>
+          </a:fontRef>
+        </p:style>
+      </p:cxnSp>
+      <p:grpSp>
+        <p:nvGrpSpPr>
+          <p:cNvPr id="36" name="Group 35">
+            <a:extLst>
+              <a:ext uri="{FF2B5EF4-FFF2-40B4-BE49-F238E27FC236}">
+                <a16:creationId xmlns:a16="http://schemas.microsoft.com/office/drawing/2014/main" id="{6C814C39-FCAF-4342-38F0-62F605913004}"/>
+              </a:ext>
+            </a:extLst>
+          </p:cNvPr>
+          <p:cNvGrpSpPr/>
+          <p:nvPr/>
+        </p:nvGrpSpPr>
+        <p:grpSpPr>
+          <a:xfrm>
+            <a:off x="7063530" y="3266395"/>
+            <a:ext cx="151694" cy="171029"/>
+            <a:chOff x="4873292" y="581648"/>
+            <a:chExt cx="151694" cy="171029"/>
+          </a:xfrm>
+        </p:grpSpPr>
+        <p:sp>
+          <p:nvSpPr>
+            <p:cNvPr id="38" name="Line 104">
+              <a:extLst>
+                <a:ext uri="{FF2B5EF4-FFF2-40B4-BE49-F238E27FC236}">
+                  <a16:creationId xmlns:a16="http://schemas.microsoft.com/office/drawing/2014/main" id="{B8039899-CACA-4049-2F83-8B9A13759B07}"/>
+                </a:ext>
+              </a:extLst>
+            </p:cNvPr>
+            <p:cNvSpPr>
+              <a:spLocks noChangeShapeType="1"/>
+            </p:cNvSpPr>
+            <p:nvPr/>
+          </p:nvSpPr>
+          <p:spPr bwMode="auto">
+            <a:xfrm flipH="1" flipV="1">
+              <a:off x="4900280" y="581648"/>
+              <a:ext cx="0" cy="40770"/>
+            </a:xfrm>
+            <a:prstGeom prst="line">
+              <a:avLst/>
+            </a:prstGeom>
+            <a:noFill/>
+            <a:ln w="8890">
+              <a:solidFill>
+                <a:schemeClr val="tx1"/>
+              </a:solidFill>
+              <a:round/>
+              <a:headEnd/>
+              <a:tailEnd type="stealth" w="med" len="med"/>
+            </a:ln>
+          </p:spPr>
+          <p:txBody>
+            <a:bodyPr lIns="90000" tIns="46800" rIns="90000" bIns="46800" anchor="ctr"/>
+            <a:lstStyle/>
+            <a:p>
+              <a:endParaRPr lang="en-US"/>
+            </a:p>
+          </p:txBody>
+        </p:sp>
+        <p:sp>
+          <p:nvSpPr>
+            <p:cNvPr id="39" name="Text Box 105">
+              <a:extLst>
+                <a:ext uri="{FF2B5EF4-FFF2-40B4-BE49-F238E27FC236}">
+                  <a16:creationId xmlns:a16="http://schemas.microsoft.com/office/drawing/2014/main" id="{A4D8E771-DE32-FB3F-2EA8-953093F0EC89}"/>
+                </a:ext>
+              </a:extLst>
+            </p:cNvPr>
+            <p:cNvSpPr txBox="1">
+              <a:spLocks noChangeArrowheads="1"/>
+            </p:cNvSpPr>
+            <p:nvPr/>
+          </p:nvSpPr>
+          <p:spPr bwMode="auto">
+            <a:xfrm>
+              <a:off x="4873292" y="630439"/>
+              <a:ext cx="85725" cy="122238"/>
+            </a:xfrm>
+            <a:prstGeom prst="rect">
+              <a:avLst/>
+            </a:prstGeom>
+            <a:noFill/>
+            <a:ln w="12700">
+              <a:noFill/>
+              <a:miter lim="800000"/>
+              <a:headEnd/>
+              <a:tailEnd/>
+            </a:ln>
+          </p:spPr>
+          <p:txBody>
+            <a:bodyPr lIns="0" tIns="0" rIns="0" bIns="0">
+              <a:spAutoFit/>
+            </a:bodyPr>
+            <a:lstStyle/>
+            <a:p>
+              <a:pPr algn="l">
+                <a:buClrTx/>
+                <a:buSzTx/>
+                <a:buFontTx/>
+                <a:buNone/>
+              </a:pPr>
+              <a:r>
+                <a:rPr lang="en-US" sz="800" b="1"/>
+                <a:t>R</a:t>
+              </a:r>
+            </a:p>
+          </p:txBody>
+        </p:sp>
+        <p:sp>
+          <p:nvSpPr>
+            <p:cNvPr id="40" name="AutoShape 76">
+              <a:extLst>
+                <a:ext uri="{FF2B5EF4-FFF2-40B4-BE49-F238E27FC236}">
+                  <a16:creationId xmlns:a16="http://schemas.microsoft.com/office/drawing/2014/main" id="{645DDF9C-8AE4-6F8B-A5D2-8407C9EC80DB}"/>
+                </a:ext>
+              </a:extLst>
+            </p:cNvPr>
+            <p:cNvSpPr>
+              <a:spLocks noChangeArrowheads="1"/>
+            </p:cNvSpPr>
+            <p:nvPr/>
+          </p:nvSpPr>
+          <p:spPr bwMode="auto">
+            <a:xfrm rot="5400000">
+              <a:off x="4952986" y="623443"/>
+              <a:ext cx="72000" cy="72000"/>
+            </a:xfrm>
+            <a:prstGeom prst="flowChartConnector">
+              <a:avLst/>
+            </a:prstGeom>
+            <a:solidFill>
+              <a:schemeClr val="bg1"/>
+            </a:solidFill>
+            <a:ln w="17780">
+              <a:solidFill>
+                <a:schemeClr val="tx1"/>
+              </a:solidFill>
+              <a:round/>
+              <a:headEnd/>
+              <a:tailEnd/>
+            </a:ln>
+          </p:spPr>
+          <p:txBody>
+            <a:bodyPr wrap="none" lIns="90000" tIns="46800" rIns="90000" bIns="46800" anchor="ctr"/>
+            <a:lstStyle/>
+            <a:p>
+              <a:endParaRPr lang="en-US"/>
+            </a:p>
+          </p:txBody>
+        </p:sp>
+      </p:grpSp>
+      <p:cxnSp>
+        <p:nvCxnSpPr>
+          <p:cNvPr id="63" name="Elbow Connector 62">
+            <a:extLst>
+              <a:ext uri="{FF2B5EF4-FFF2-40B4-BE49-F238E27FC236}">
+                <a16:creationId xmlns:a16="http://schemas.microsoft.com/office/drawing/2014/main" id="{AA5E100F-C598-75C2-0DF8-7D652A701A4F}"/>
+              </a:ext>
+            </a:extLst>
+          </p:cNvPr>
+          <p:cNvCxnSpPr>
+            <a:cxnSpLocks/>
+            <a:stCxn id="539" idx="3"/>
+            <a:endCxn id="495" idx="2"/>
+          </p:cNvCxnSpPr>
+          <p:nvPr/>
+        </p:nvCxnSpPr>
+        <p:spPr>
+          <a:xfrm>
+            <a:off x="6614752" y="4640040"/>
+            <a:ext cx="603146" cy="616539"/>
+          </a:xfrm>
+          <a:prstGeom prst="bentConnector2">
+            <a:avLst/>
+          </a:prstGeom>
+          <a:ln w="12700">
+            <a:solidFill>
+              <a:schemeClr val="tx1"/>
+            </a:solidFill>
+          </a:ln>
+        </p:spPr>
+        <p:style>
+          <a:lnRef idx="1">
+            <a:schemeClr val="accent1"/>
+          </a:lnRef>
+          <a:fillRef idx="0">
+            <a:schemeClr val="accent1"/>
+          </a:fillRef>
+          <a:effectRef idx="0">
+            <a:schemeClr val="accent1"/>
+          </a:effectRef>
+          <a:fontRef idx="minor">
+            <a:schemeClr val="tx1"/>
+          </a:fontRef>
+        </p:style>
+      </p:cxnSp>
+      <p:cxnSp>
+        <p:nvCxnSpPr>
+          <p:cNvPr id="66" name="Elbow Connector 65">
+            <a:extLst>
+              <a:ext uri="{FF2B5EF4-FFF2-40B4-BE49-F238E27FC236}">
+                <a16:creationId xmlns:a16="http://schemas.microsoft.com/office/drawing/2014/main" id="{90C677B5-929F-190C-5B5E-29AD1BF292BB}"/>
+              </a:ext>
+            </a:extLst>
+          </p:cNvPr>
+          <p:cNvCxnSpPr>
+            <a:cxnSpLocks/>
+            <a:stCxn id="495" idx="0"/>
+            <a:endCxn id="437" idx="3"/>
+          </p:cNvCxnSpPr>
+          <p:nvPr/>
+        </p:nvCxnSpPr>
+        <p:spPr>
+          <a:xfrm rot="10800000">
+            <a:off x="6611152" y="5292361"/>
+            <a:ext cx="570746" cy="219"/>
+          </a:xfrm>
+          <a:prstGeom prst="bentConnector3">
+            <a:avLst>
+              <a:gd name="adj1" fmla="val 50000"/>
+            </a:avLst>
+          </a:prstGeom>
+          <a:ln w="12700">
+            <a:solidFill>
+              <a:schemeClr val="tx1"/>
+            </a:solidFill>
+          </a:ln>
+        </p:spPr>
+        <p:style>
+          <a:lnRef idx="1">
+            <a:schemeClr val="accent1"/>
+          </a:lnRef>
+          <a:fillRef idx="0">
+            <a:schemeClr val="accent1"/>
+          </a:fillRef>
+          <a:effectRef idx="0">
+            <a:schemeClr val="accent1"/>
+          </a:effectRef>
+          <a:fontRef idx="minor">
+            <a:schemeClr val="tx1"/>
+          </a:fontRef>
+        </p:style>
+      </p:cxnSp>
+      <p:cxnSp>
+        <p:nvCxnSpPr>
+          <p:cNvPr id="69" name="Elbow Connector 68">
+            <a:extLst>
+              <a:ext uri="{FF2B5EF4-FFF2-40B4-BE49-F238E27FC236}">
+                <a16:creationId xmlns:a16="http://schemas.microsoft.com/office/drawing/2014/main" id="{8DE10120-B5A8-71F9-3165-55438E9AE00C}"/>
+              </a:ext>
+            </a:extLst>
+          </p:cNvPr>
+          <p:cNvCxnSpPr>
+            <a:cxnSpLocks/>
+            <a:stCxn id="495" idx="0"/>
+            <a:endCxn id="435" idx="3"/>
+          </p:cNvCxnSpPr>
+          <p:nvPr/>
+        </p:nvCxnSpPr>
+        <p:spPr>
+          <a:xfrm rot="10800000">
+            <a:off x="6614752" y="5074921"/>
+            <a:ext cx="567146" cy="217659"/>
+          </a:xfrm>
+          <a:prstGeom prst="bentConnector3">
+            <a:avLst>
+              <a:gd name="adj1" fmla="val 50000"/>
+            </a:avLst>
+          </a:prstGeom>
+          <a:ln w="12700">
+            <a:solidFill>
+              <a:schemeClr val="tx1"/>
+            </a:solidFill>
+          </a:ln>
+        </p:spPr>
+        <p:style>
+          <a:lnRef idx="1">
+            <a:schemeClr val="accent1"/>
+          </a:lnRef>
+          <a:fillRef idx="0">
+            <a:schemeClr val="accent1"/>
+          </a:fillRef>
+          <a:effectRef idx="0">
+            <a:schemeClr val="accent1"/>
+          </a:effectRef>
+          <a:fontRef idx="minor">
+            <a:schemeClr val="tx1"/>
+          </a:fontRef>
+        </p:style>
+      </p:cxnSp>
+      <p:cxnSp>
+        <p:nvCxnSpPr>
+          <p:cNvPr id="73" name="Elbow Connector 72">
+            <a:extLst>
+              <a:ext uri="{FF2B5EF4-FFF2-40B4-BE49-F238E27FC236}">
+                <a16:creationId xmlns:a16="http://schemas.microsoft.com/office/drawing/2014/main" id="{9C7A0F97-D766-B5CD-42C3-26AD94A30B5D}"/>
+              </a:ext>
+            </a:extLst>
+          </p:cNvPr>
+          <p:cNvCxnSpPr>
+            <a:cxnSpLocks/>
+            <a:stCxn id="495" idx="0"/>
+          </p:cNvCxnSpPr>
+          <p:nvPr/>
+        </p:nvCxnSpPr>
+        <p:spPr>
+          <a:xfrm rot="10800000" flipV="1">
+            <a:off x="6614752" y="5292578"/>
+            <a:ext cx="567146" cy="173965"/>
+          </a:xfrm>
+          <a:prstGeom prst="bentConnector3">
+            <a:avLst>
+              <a:gd name="adj1" fmla="val 50000"/>
+            </a:avLst>
+          </a:prstGeom>
+          <a:ln w="12700">
+            <a:solidFill>
+              <a:schemeClr val="tx1"/>
+            </a:solidFill>
+          </a:ln>
+        </p:spPr>
+        <p:style>
+          <a:lnRef idx="1">
+            <a:schemeClr val="accent1"/>
+          </a:lnRef>
+          <a:fillRef idx="0">
+            <a:schemeClr val="accent1"/>
+          </a:fillRef>
+          <a:effectRef idx="0">
+            <a:schemeClr val="accent1"/>
+          </a:effectRef>
+          <a:fontRef idx="minor">
+            <a:schemeClr val="tx1"/>
+          </a:fontRef>
+        </p:style>
+      </p:cxnSp>
+      <p:cxnSp>
+        <p:nvCxnSpPr>
+          <p:cNvPr id="80" name="Elbow Connector 79">
+            <a:extLst>
+              <a:ext uri="{FF2B5EF4-FFF2-40B4-BE49-F238E27FC236}">
+                <a16:creationId xmlns:a16="http://schemas.microsoft.com/office/drawing/2014/main" id="{C39D9B4C-580F-9F77-B2DC-47789D8DDD38}"/>
+              </a:ext>
+            </a:extLst>
+          </p:cNvPr>
+          <p:cNvCxnSpPr>
+            <a:cxnSpLocks/>
+            <a:stCxn id="296" idx="4"/>
+            <a:endCxn id="465" idx="3"/>
+          </p:cNvCxnSpPr>
+          <p:nvPr/>
+        </p:nvCxnSpPr>
+        <p:spPr>
+          <a:xfrm flipH="1">
+            <a:off x="6614752" y="6072790"/>
+            <a:ext cx="1020653" cy="2210"/>
+          </a:xfrm>
+          <a:prstGeom prst="straightConnector1">
+            <a:avLst/>
+          </a:prstGeom>
+          <a:ln w="12700">
+            <a:solidFill>
+              <a:schemeClr val="tx1"/>
+            </a:solidFill>
+          </a:ln>
+        </p:spPr>
+        <p:style>
+          <a:lnRef idx="1">
+            <a:schemeClr val="accent1"/>
+          </a:lnRef>
+          <a:fillRef idx="0">
+            <a:schemeClr val="accent1"/>
+          </a:fillRef>
+          <a:effectRef idx="0">
+            <a:schemeClr val="accent1"/>
+          </a:effectRef>
+          <a:fontRef idx="minor">
+            <a:schemeClr val="tx1"/>
+          </a:fontRef>
+        </p:style>
+      </p:cxnSp>
+      <p:cxnSp>
+        <p:nvCxnSpPr>
+          <p:cNvPr id="104" name="Elbow Connector 103">
+            <a:extLst>
+              <a:ext uri="{FF2B5EF4-FFF2-40B4-BE49-F238E27FC236}">
+                <a16:creationId xmlns:a16="http://schemas.microsoft.com/office/drawing/2014/main" id="{3B7EAAFC-E4F3-9AA8-0FCC-EC525DD2D7E8}"/>
+              </a:ext>
+            </a:extLst>
+          </p:cNvPr>
+          <p:cNvCxnSpPr>
+            <a:cxnSpLocks/>
+            <a:endCxn id="296" idx="0"/>
+          </p:cNvCxnSpPr>
+          <p:nvPr/>
+        </p:nvCxnSpPr>
+        <p:spPr>
+          <a:xfrm flipH="1">
+            <a:off x="7707405" y="6072783"/>
+            <a:ext cx="99750" cy="7"/>
+          </a:xfrm>
+          <a:prstGeom prst="straightConnector1">
+            <a:avLst/>
+          </a:prstGeom>
+          <a:ln w="12700">
+            <a:solidFill>
+              <a:schemeClr val="tx1"/>
+            </a:solidFill>
+          </a:ln>
+        </p:spPr>
+        <p:style>
+          <a:lnRef idx="1">
+            <a:schemeClr val="accent1"/>
+          </a:lnRef>
+          <a:fillRef idx="0">
+            <a:schemeClr val="accent1"/>
+          </a:fillRef>
+          <a:effectRef idx="0">
+            <a:schemeClr val="accent1"/>
+          </a:effectRef>
+          <a:fontRef idx="minor">
+            <a:schemeClr val="tx1"/>
+          </a:fontRef>
+        </p:style>
+      </p:cxnSp>
+      <p:cxnSp>
+        <p:nvCxnSpPr>
+          <p:cNvPr id="112" name="Elbow Connector 111">
+            <a:extLst>
+              <a:ext uri="{FF2B5EF4-FFF2-40B4-BE49-F238E27FC236}">
+                <a16:creationId xmlns:a16="http://schemas.microsoft.com/office/drawing/2014/main" id="{1C764552-2426-C21D-B4FD-426D9589B834}"/>
+              </a:ext>
+            </a:extLst>
+          </p:cNvPr>
+          <p:cNvCxnSpPr>
+            <a:cxnSpLocks/>
+          </p:cNvCxnSpPr>
+          <p:nvPr/>
+        </p:nvCxnSpPr>
+        <p:spPr>
+          <a:xfrm rot="16200000" flipV="1">
+            <a:off x="5953609" y="4223074"/>
+            <a:ext cx="3652493" cy="45897"/>
+          </a:xfrm>
+          <a:prstGeom prst="bentConnector3">
+            <a:avLst>
+              <a:gd name="adj1" fmla="val 80511"/>
+            </a:avLst>
+          </a:prstGeom>
+          <a:ln w="12700">
+            <a:solidFill>
+              <a:schemeClr val="tx1"/>
+            </a:solidFill>
+          </a:ln>
+        </p:spPr>
+        <p:style>
+          <a:lnRef idx="1">
+            <a:schemeClr val="accent1"/>
+          </a:lnRef>
+          <a:fillRef idx="0">
+            <a:schemeClr val="accent1"/>
+          </a:fillRef>
+          <a:effectRef idx="0">
+            <a:schemeClr val="accent1"/>
+          </a:effectRef>
+          <a:fontRef idx="minor">
+            <a:schemeClr val="tx1"/>
+          </a:fontRef>
+        </p:style>
+      </p:cxnSp>
     </p:spTree>
     <p:extLst>
       <p:ext uri="{BB962C8B-B14F-4D97-AF65-F5344CB8AC3E}">
@@ -18777,4 +19249,10 @@
     </a:ext>
   </a:extLst>
 </a:theme>
+</file>
+
+<file path=docMetadata/LabelInfo.xml><?xml version="1.0" encoding="utf-8"?>
+<clbl:labelList xmlns:clbl="http://schemas.microsoft.com/office/2020/mipLabelMetadata">
+  <clbl:label id="{0cf7ac0a-4681-4823-ab0b-04ef02c5f873}" enabled="1" method="Standard" siteId="{42f7676c-f455-423c-82f6-dc2d99791af7}" contentBits="0" removed="0"/>
+</clbl:labelList>
 </file>
</xml_diff>

<commit_message>
Update Gardener Architecture Diagram (#15699)
The following changes were made:
- The cluster ingress is always handled by istio ingress gateway. This
  applies to both virtual garden cluster as well as seed cluster.
- Gardenlet communicates with the seed cluster api server.
- The control plane components communicate with the api server.
- The data plane metrics are collected via the api server.
- The logging data is transferred via the istio ingress gateway to the
  logging component.

Signed-off-by: Johannes Scheerer <johannes.scheerer@sap.com>
</commit_message>
<xml_diff>
--- a/docs/concepts/images/gardener-architecture-detailed.pptx
+++ b/docs/concepts/images/gardener-architecture-detailed.pptx
@@ -197,7 +197,7 @@
           <a:p>
             <a:fld id="{13E0A233-D006-1049-96B2-56CCC883D470}" type="datetimeFigureOut">
               <a:rPr lang="en-DE" smtClean="0"/>
-              <a:t>20.09.22</a:t>
+              <a:t>10.09.26</a:t>
             </a:fld>
             <a:endParaRPr lang="en-DE"/>
           </a:p>
@@ -698,7 +698,7 @@
           <a:p>
             <a:fld id="{34148265-B100-ED48-B1D9-7B0C2D8678E5}" type="datetimeFigureOut">
               <a:rPr lang="en-DE" smtClean="0"/>
-              <a:t>20.09.22</a:t>
+              <a:t>10.09.26</a:t>
             </a:fld>
             <a:endParaRPr lang="en-DE"/>
           </a:p>
@@ -898,7 +898,7 @@
           <a:p>
             <a:fld id="{34148265-B100-ED48-B1D9-7B0C2D8678E5}" type="datetimeFigureOut">
               <a:rPr lang="en-DE" smtClean="0"/>
-              <a:t>20.09.22</a:t>
+              <a:t>10.09.26</a:t>
             </a:fld>
             <a:endParaRPr lang="en-DE"/>
           </a:p>
@@ -1108,7 +1108,7 @@
           <a:p>
             <a:fld id="{34148265-B100-ED48-B1D9-7B0C2D8678E5}" type="datetimeFigureOut">
               <a:rPr lang="en-DE" smtClean="0"/>
-              <a:t>20.09.22</a:t>
+              <a:t>10.09.26</a:t>
             </a:fld>
             <a:endParaRPr lang="en-DE"/>
           </a:p>
@@ -1308,7 +1308,7 @@
           <a:p>
             <a:fld id="{34148265-B100-ED48-B1D9-7B0C2D8678E5}" type="datetimeFigureOut">
               <a:rPr lang="en-DE" smtClean="0"/>
-              <a:t>20.09.22</a:t>
+              <a:t>10.09.26</a:t>
             </a:fld>
             <a:endParaRPr lang="en-DE"/>
           </a:p>
@@ -1584,7 +1584,7 @@
           <a:p>
             <a:fld id="{34148265-B100-ED48-B1D9-7B0C2D8678E5}" type="datetimeFigureOut">
               <a:rPr lang="en-DE" smtClean="0"/>
-              <a:t>20.09.22</a:t>
+              <a:t>10.09.26</a:t>
             </a:fld>
             <a:endParaRPr lang="en-DE"/>
           </a:p>
@@ -1852,7 +1852,7 @@
           <a:p>
             <a:fld id="{34148265-B100-ED48-B1D9-7B0C2D8678E5}" type="datetimeFigureOut">
               <a:rPr lang="en-DE" smtClean="0"/>
-              <a:t>20.09.22</a:t>
+              <a:t>10.09.26</a:t>
             </a:fld>
             <a:endParaRPr lang="en-DE"/>
           </a:p>
@@ -2267,7 +2267,7 @@
           <a:p>
             <a:fld id="{34148265-B100-ED48-B1D9-7B0C2D8678E5}" type="datetimeFigureOut">
               <a:rPr lang="en-DE" smtClean="0"/>
-              <a:t>20.09.22</a:t>
+              <a:t>10.09.26</a:t>
             </a:fld>
             <a:endParaRPr lang="en-DE"/>
           </a:p>
@@ -2409,7 +2409,7 @@
           <a:p>
             <a:fld id="{34148265-B100-ED48-B1D9-7B0C2D8678E5}" type="datetimeFigureOut">
               <a:rPr lang="en-DE" smtClean="0"/>
-              <a:t>20.09.22</a:t>
+              <a:t>10.09.26</a:t>
             </a:fld>
             <a:endParaRPr lang="en-DE"/>
           </a:p>
@@ -2522,7 +2522,7 @@
           <a:p>
             <a:fld id="{34148265-B100-ED48-B1D9-7B0C2D8678E5}" type="datetimeFigureOut">
               <a:rPr lang="en-DE" smtClean="0"/>
-              <a:t>20.09.22</a:t>
+              <a:t>10.09.26</a:t>
             </a:fld>
             <a:endParaRPr lang="en-DE"/>
           </a:p>
@@ -2835,7 +2835,7 @@
           <a:p>
             <a:fld id="{34148265-B100-ED48-B1D9-7B0C2D8678E5}" type="datetimeFigureOut">
               <a:rPr lang="en-DE" smtClean="0"/>
-              <a:t>20.09.22</a:t>
+              <a:t>10.09.26</a:t>
             </a:fld>
             <a:endParaRPr lang="en-DE"/>
           </a:p>
@@ -3124,7 +3124,7 @@
           <a:p>
             <a:fld id="{34148265-B100-ED48-B1D9-7B0C2D8678E5}" type="datetimeFigureOut">
               <a:rPr lang="en-DE" smtClean="0"/>
-              <a:t>20.09.22</a:t>
+              <a:t>10.09.26</a:t>
             </a:fld>
             <a:endParaRPr lang="en-DE"/>
           </a:p>
@@ -3367,7 +3367,7 @@
           <a:p>
             <a:fld id="{34148265-B100-ED48-B1D9-7B0C2D8678E5}" type="datetimeFigureOut">
               <a:rPr lang="en-DE" smtClean="0"/>
-              <a:t>20.09.22</a:t>
+              <a:t>10.09.26</a:t>
             </a:fld>
             <a:endParaRPr lang="en-DE"/>
           </a:p>
@@ -4775,7 +4775,7 @@
           <a:p>
             <a:pPr algn="ctr"/>
             <a:r>
-              <a:rPr lang="en-US" sz="1200"/>
+              <a:rPr lang="en-US" sz="1200" dirty="0"/>
               <a:t>Seed Cluster API LB</a:t>
             </a:r>
           </a:p>
@@ -5115,7 +5115,7 @@
       </p:sp>
       <p:sp>
         <p:nvSpPr>
-          <p:cNvPr id="211" name="Rectangle 138"/>
+          <p:cNvPr id="212" name="Rectangle 138"/>
           <p:cNvSpPr>
             <a:spLocks noChangeArrowheads="1"/>
           </p:cNvSpPr>
@@ -5123,8 +5123,8 @@
         </p:nvSpPr>
         <p:spPr bwMode="auto">
           <a:xfrm>
-            <a:off x="2744949" y="2208506"/>
-            <a:ext cx="1238961" cy="206532"/>
+            <a:off x="1088006" y="2208506"/>
+            <a:ext cx="2887198" cy="206532"/>
           </a:xfrm>
           <a:prstGeom prst="rect">
             <a:avLst/>
@@ -5151,50 +5151,7 @@
             <a:pPr algn="ctr"/>
             <a:r>
               <a:rPr lang="en-US" sz="1200" dirty="0"/>
-              <a:t>Ingress LB</a:t>
-            </a:r>
-          </a:p>
-        </p:txBody>
-      </p:sp>
-      <p:sp>
-        <p:nvSpPr>
-          <p:cNvPr id="212" name="Rectangle 138"/>
-          <p:cNvSpPr>
-            <a:spLocks noChangeArrowheads="1"/>
-          </p:cNvSpPr>
-          <p:nvPr/>
-        </p:nvSpPr>
-        <p:spPr bwMode="auto">
-          <a:xfrm>
-            <a:off x="1088006" y="2208506"/>
-            <a:ext cx="1504397" cy="206532"/>
-          </a:xfrm>
-          <a:prstGeom prst="rect">
-            <a:avLst/>
-          </a:prstGeom>
-          <a:solidFill>
-            <a:schemeClr val="accent6">
-              <a:lumMod val="40000"/>
-              <a:lumOff val="60000"/>
-            </a:schemeClr>
-          </a:solidFill>
-          <a:ln w="17780">
-            <a:solidFill>
-              <a:schemeClr val="tx1"/>
-            </a:solidFill>
-            <a:miter lim="800000"/>
-            <a:headEnd/>
-            <a:tailEnd/>
-          </a:ln>
-        </p:spPr>
-        <p:txBody>
-          <a:bodyPr lIns="36000" tIns="36000" rIns="36000" bIns="36000" anchor="ctr"/>
-          <a:lstStyle/>
-          <a:p>
-            <a:pPr algn="ctr"/>
-            <a:r>
-              <a:rPr lang="en-US" sz="1200"/>
-              <a:t>Garden Cluster API LB</a:t>
+              <a:t>Virtual Garden Istio Ingress Gateway LB</a:t>
             </a:r>
           </a:p>
         </p:txBody>
@@ -7585,7 +7542,7 @@
         </p:nvGrpSpPr>
         <p:grpSpPr>
           <a:xfrm>
-            <a:off x="-325890" y="6590078"/>
+            <a:off x="7594740" y="5918979"/>
             <a:ext cx="161055" cy="189811"/>
             <a:chOff x="6020928" y="505632"/>
             <a:chExt cx="161055" cy="189811"/>
@@ -14588,12 +14545,12 @@
         </p:nvCxnSpPr>
         <p:spPr>
           <a:xfrm rot="10800000">
-            <a:off x="5722477" y="3010255"/>
-            <a:ext cx="1101677" cy="125432"/>
+            <a:off x="5724209" y="3006932"/>
+            <a:ext cx="1451318" cy="119904"/>
           </a:xfrm>
           <a:prstGeom prst="bentConnector3">
             <a:avLst>
-              <a:gd name="adj1" fmla="val 101876"/>
+              <a:gd name="adj1" fmla="val 100146"/>
             </a:avLst>
           </a:prstGeom>
           <a:ln w="12700">
@@ -14968,7 +14925,7 @@
                 <a:buNone/>
               </a:pPr>
               <a:r>
-                <a:rPr lang="en-US" sz="800" b="1"/>
+                <a:rPr lang="en-US" sz="800" b="1" dirty="0"/>
                 <a:t>R</a:t>
               </a:r>
             </a:p>
@@ -15071,7 +15028,7 @@
         </p:nvGrpSpPr>
         <p:grpSpPr>
           <a:xfrm>
-            <a:off x="7527636" y="6030736"/>
+            <a:off x="7527636" y="5204629"/>
             <a:ext cx="180269" cy="171451"/>
             <a:chOff x="5145186" y="193240"/>
             <a:chExt cx="180269" cy="171451"/>
@@ -16005,49 +15962,6 @@
           </p:txBody>
         </p:sp>
       </p:grpSp>
-      <p:sp>
-        <p:nvSpPr>
-          <p:cNvPr id="537" name="Rectangle 138"/>
-          <p:cNvSpPr>
-            <a:spLocks noChangeArrowheads="1"/>
-          </p:cNvSpPr>
-          <p:nvPr/>
-        </p:nvSpPr>
-        <p:spPr bwMode="auto">
-          <a:xfrm>
-            <a:off x="6192367" y="2208506"/>
-            <a:ext cx="1596283" cy="206532"/>
-          </a:xfrm>
-          <a:prstGeom prst="rect">
-            <a:avLst/>
-          </a:prstGeom>
-          <a:solidFill>
-            <a:schemeClr val="accent5">
-              <a:lumMod val="40000"/>
-              <a:lumOff val="60000"/>
-            </a:schemeClr>
-          </a:solidFill>
-          <a:ln w="17780">
-            <a:solidFill>
-              <a:schemeClr val="tx1"/>
-            </a:solidFill>
-            <a:miter lim="800000"/>
-            <a:headEnd/>
-            <a:tailEnd/>
-          </a:ln>
-        </p:spPr>
-        <p:txBody>
-          <a:bodyPr lIns="36000" tIns="36000" rIns="36000" bIns="36000" anchor="ctr"/>
-          <a:lstStyle/>
-          <a:p>
-            <a:pPr algn="ctr"/>
-            <a:r>
-              <a:rPr lang="en-US" sz="1200" dirty="0"/>
-              <a:t>Istio Ingress Gateway LB</a:t>
-            </a:r>
-          </a:p>
-        </p:txBody>
-      </p:sp>
       <p:grpSp>
         <p:nvGrpSpPr>
           <p:cNvPr id="397" name="Group 396">
@@ -16939,18 +16853,18 @@
           </p:cNvPr>
           <p:cNvCxnSpPr>
             <a:cxnSpLocks/>
+            <a:stCxn id="495" idx="6"/>
+            <a:endCxn id="464" idx="3"/>
           </p:cNvCxnSpPr>
           <p:nvPr/>
         </p:nvCxnSpPr>
         <p:spPr>
-          <a:xfrm>
-            <a:off x="6614752" y="4902915"/>
-            <a:ext cx="573" cy="931501"/>
-          </a:xfrm>
-          <a:prstGeom prst="bentConnector3">
-            <a:avLst>
-              <a:gd name="adj1" fmla="val 39995288"/>
-            </a:avLst>
+          <a:xfrm rot="5400000">
+            <a:off x="6647515" y="5295816"/>
+            <a:ext cx="537621" cy="603146"/>
+          </a:xfrm>
+          <a:prstGeom prst="bentConnector2">
+            <a:avLst/>
           </a:prstGeom>
           <a:ln w="12700">
             <a:solidFill>
@@ -17139,7 +17053,7 @@
         </p:nvGrpSpPr>
         <p:grpSpPr>
           <a:xfrm>
-            <a:off x="6808680" y="5669421"/>
+            <a:off x="7181898" y="5214784"/>
             <a:ext cx="180269" cy="171029"/>
             <a:chOff x="5145186" y="581648"/>
             <a:chExt cx="180269" cy="171029"/>
@@ -18176,6 +18090,564 @@
           </a:p>
         </p:txBody>
       </p:sp>
+      <p:sp>
+        <p:nvSpPr>
+          <p:cNvPr id="537" name="Rectangle 138"/>
+          <p:cNvSpPr>
+            <a:spLocks noChangeArrowheads="1"/>
+          </p:cNvSpPr>
+          <p:nvPr/>
+        </p:nvSpPr>
+        <p:spPr bwMode="auto">
+          <a:xfrm>
+            <a:off x="6192367" y="2208506"/>
+            <a:ext cx="1596283" cy="206532"/>
+          </a:xfrm>
+          <a:prstGeom prst="rect">
+            <a:avLst/>
+          </a:prstGeom>
+          <a:solidFill>
+            <a:schemeClr val="accent5">
+              <a:lumMod val="40000"/>
+              <a:lumOff val="60000"/>
+            </a:schemeClr>
+          </a:solidFill>
+          <a:ln w="17780">
+            <a:solidFill>
+              <a:schemeClr val="tx1"/>
+            </a:solidFill>
+            <a:miter lim="800000"/>
+            <a:headEnd/>
+            <a:tailEnd/>
+          </a:ln>
+        </p:spPr>
+        <p:txBody>
+          <a:bodyPr lIns="36000" tIns="36000" rIns="36000" bIns="36000" anchor="ctr"/>
+          <a:lstStyle/>
+          <a:p>
+            <a:pPr algn="ctr"/>
+            <a:r>
+              <a:rPr lang="en-US" sz="1200" dirty="0"/>
+              <a:t>Istio Ingress Gateway LB</a:t>
+            </a:r>
+          </a:p>
+        </p:txBody>
+      </p:sp>
+      <p:cxnSp>
+        <p:nvCxnSpPr>
+          <p:cNvPr id="35" name="Elbow Connector 34">
+            <a:extLst>
+              <a:ext uri="{FF2B5EF4-FFF2-40B4-BE49-F238E27FC236}">
+                <a16:creationId xmlns:a16="http://schemas.microsoft.com/office/drawing/2014/main" id="{68526CB4-62BB-B754-1989-61490BADA2D0}"/>
+              </a:ext>
+            </a:extLst>
+          </p:cNvPr>
+          <p:cNvCxnSpPr>
+            <a:cxnSpLocks/>
+            <a:endCxn id="494" idx="3"/>
+          </p:cNvCxnSpPr>
+          <p:nvPr/>
+        </p:nvCxnSpPr>
+        <p:spPr>
+          <a:xfrm rot="5400000">
+            <a:off x="6728207" y="3431114"/>
+            <a:ext cx="753296" cy="133495"/>
+          </a:xfrm>
+          <a:prstGeom prst="bentConnector2">
+            <a:avLst/>
+          </a:prstGeom>
+          <a:ln w="12700">
+            <a:solidFill>
+              <a:schemeClr val="tx1"/>
+            </a:solidFill>
+          </a:ln>
+        </p:spPr>
+        <p:style>
+          <a:lnRef idx="1">
+            <a:schemeClr val="accent1"/>
+          </a:lnRef>
+          <a:fillRef idx="0">
+            <a:schemeClr val="accent1"/>
+          </a:fillRef>
+          <a:effectRef idx="0">
+            <a:schemeClr val="accent1"/>
+          </a:effectRef>
+          <a:fontRef idx="minor">
+            <a:schemeClr val="tx1"/>
+          </a:fontRef>
+        </p:style>
+      </p:cxnSp>
+      <p:grpSp>
+        <p:nvGrpSpPr>
+          <p:cNvPr id="36" name="Group 35">
+            <a:extLst>
+              <a:ext uri="{FF2B5EF4-FFF2-40B4-BE49-F238E27FC236}">
+                <a16:creationId xmlns:a16="http://schemas.microsoft.com/office/drawing/2014/main" id="{6C814C39-FCAF-4342-38F0-62F605913004}"/>
+              </a:ext>
+            </a:extLst>
+          </p:cNvPr>
+          <p:cNvGrpSpPr/>
+          <p:nvPr/>
+        </p:nvGrpSpPr>
+        <p:grpSpPr>
+          <a:xfrm>
+            <a:off x="7063530" y="3266395"/>
+            <a:ext cx="151694" cy="171029"/>
+            <a:chOff x="4873292" y="581648"/>
+            <a:chExt cx="151694" cy="171029"/>
+          </a:xfrm>
+        </p:grpSpPr>
+        <p:sp>
+          <p:nvSpPr>
+            <p:cNvPr id="38" name="Line 104">
+              <a:extLst>
+                <a:ext uri="{FF2B5EF4-FFF2-40B4-BE49-F238E27FC236}">
+                  <a16:creationId xmlns:a16="http://schemas.microsoft.com/office/drawing/2014/main" id="{B8039899-CACA-4049-2F83-8B9A13759B07}"/>
+                </a:ext>
+              </a:extLst>
+            </p:cNvPr>
+            <p:cNvSpPr>
+              <a:spLocks noChangeShapeType="1"/>
+            </p:cNvSpPr>
+            <p:nvPr/>
+          </p:nvSpPr>
+          <p:spPr bwMode="auto">
+            <a:xfrm flipH="1" flipV="1">
+              <a:off x="4900280" y="581648"/>
+              <a:ext cx="0" cy="40770"/>
+            </a:xfrm>
+            <a:prstGeom prst="line">
+              <a:avLst/>
+            </a:prstGeom>
+            <a:noFill/>
+            <a:ln w="8890">
+              <a:solidFill>
+                <a:schemeClr val="tx1"/>
+              </a:solidFill>
+              <a:round/>
+              <a:headEnd/>
+              <a:tailEnd type="stealth" w="med" len="med"/>
+            </a:ln>
+          </p:spPr>
+          <p:txBody>
+            <a:bodyPr lIns="90000" tIns="46800" rIns="90000" bIns="46800" anchor="ctr"/>
+            <a:lstStyle/>
+            <a:p>
+              <a:endParaRPr lang="en-US"/>
+            </a:p>
+          </p:txBody>
+        </p:sp>
+        <p:sp>
+          <p:nvSpPr>
+            <p:cNvPr id="39" name="Text Box 105">
+              <a:extLst>
+                <a:ext uri="{FF2B5EF4-FFF2-40B4-BE49-F238E27FC236}">
+                  <a16:creationId xmlns:a16="http://schemas.microsoft.com/office/drawing/2014/main" id="{A4D8E771-DE32-FB3F-2EA8-953093F0EC89}"/>
+                </a:ext>
+              </a:extLst>
+            </p:cNvPr>
+            <p:cNvSpPr txBox="1">
+              <a:spLocks noChangeArrowheads="1"/>
+            </p:cNvSpPr>
+            <p:nvPr/>
+          </p:nvSpPr>
+          <p:spPr bwMode="auto">
+            <a:xfrm>
+              <a:off x="4873292" y="630439"/>
+              <a:ext cx="85725" cy="122238"/>
+            </a:xfrm>
+            <a:prstGeom prst="rect">
+              <a:avLst/>
+            </a:prstGeom>
+            <a:noFill/>
+            <a:ln w="12700">
+              <a:noFill/>
+              <a:miter lim="800000"/>
+              <a:headEnd/>
+              <a:tailEnd/>
+            </a:ln>
+          </p:spPr>
+          <p:txBody>
+            <a:bodyPr lIns="0" tIns="0" rIns="0" bIns="0">
+              <a:spAutoFit/>
+            </a:bodyPr>
+            <a:lstStyle/>
+            <a:p>
+              <a:pPr algn="l">
+                <a:buClrTx/>
+                <a:buSzTx/>
+                <a:buFontTx/>
+                <a:buNone/>
+              </a:pPr>
+              <a:r>
+                <a:rPr lang="en-US" sz="800" b="1"/>
+                <a:t>R</a:t>
+              </a:r>
+            </a:p>
+          </p:txBody>
+        </p:sp>
+        <p:sp>
+          <p:nvSpPr>
+            <p:cNvPr id="40" name="AutoShape 76">
+              <a:extLst>
+                <a:ext uri="{FF2B5EF4-FFF2-40B4-BE49-F238E27FC236}">
+                  <a16:creationId xmlns:a16="http://schemas.microsoft.com/office/drawing/2014/main" id="{645DDF9C-8AE4-6F8B-A5D2-8407C9EC80DB}"/>
+                </a:ext>
+              </a:extLst>
+            </p:cNvPr>
+            <p:cNvSpPr>
+              <a:spLocks noChangeArrowheads="1"/>
+            </p:cNvSpPr>
+            <p:nvPr/>
+          </p:nvSpPr>
+          <p:spPr bwMode="auto">
+            <a:xfrm rot="5400000">
+              <a:off x="4952986" y="623443"/>
+              <a:ext cx="72000" cy="72000"/>
+            </a:xfrm>
+            <a:prstGeom prst="flowChartConnector">
+              <a:avLst/>
+            </a:prstGeom>
+            <a:solidFill>
+              <a:schemeClr val="bg1"/>
+            </a:solidFill>
+            <a:ln w="17780">
+              <a:solidFill>
+                <a:schemeClr val="tx1"/>
+              </a:solidFill>
+              <a:round/>
+              <a:headEnd/>
+              <a:tailEnd/>
+            </a:ln>
+          </p:spPr>
+          <p:txBody>
+            <a:bodyPr wrap="none" lIns="90000" tIns="46800" rIns="90000" bIns="46800" anchor="ctr"/>
+            <a:lstStyle/>
+            <a:p>
+              <a:endParaRPr lang="en-US"/>
+            </a:p>
+          </p:txBody>
+        </p:sp>
+      </p:grpSp>
+      <p:cxnSp>
+        <p:nvCxnSpPr>
+          <p:cNvPr id="63" name="Elbow Connector 62">
+            <a:extLst>
+              <a:ext uri="{FF2B5EF4-FFF2-40B4-BE49-F238E27FC236}">
+                <a16:creationId xmlns:a16="http://schemas.microsoft.com/office/drawing/2014/main" id="{AA5E100F-C598-75C2-0DF8-7D652A701A4F}"/>
+              </a:ext>
+            </a:extLst>
+          </p:cNvPr>
+          <p:cNvCxnSpPr>
+            <a:cxnSpLocks/>
+            <a:stCxn id="539" idx="3"/>
+            <a:endCxn id="495" idx="2"/>
+          </p:cNvCxnSpPr>
+          <p:nvPr/>
+        </p:nvCxnSpPr>
+        <p:spPr>
+          <a:xfrm>
+            <a:off x="6614752" y="4640040"/>
+            <a:ext cx="603146" cy="616539"/>
+          </a:xfrm>
+          <a:prstGeom prst="bentConnector2">
+            <a:avLst/>
+          </a:prstGeom>
+          <a:ln w="12700">
+            <a:solidFill>
+              <a:schemeClr val="tx1"/>
+            </a:solidFill>
+          </a:ln>
+        </p:spPr>
+        <p:style>
+          <a:lnRef idx="1">
+            <a:schemeClr val="accent1"/>
+          </a:lnRef>
+          <a:fillRef idx="0">
+            <a:schemeClr val="accent1"/>
+          </a:fillRef>
+          <a:effectRef idx="0">
+            <a:schemeClr val="accent1"/>
+          </a:effectRef>
+          <a:fontRef idx="minor">
+            <a:schemeClr val="tx1"/>
+          </a:fontRef>
+        </p:style>
+      </p:cxnSp>
+      <p:cxnSp>
+        <p:nvCxnSpPr>
+          <p:cNvPr id="66" name="Elbow Connector 65">
+            <a:extLst>
+              <a:ext uri="{FF2B5EF4-FFF2-40B4-BE49-F238E27FC236}">
+                <a16:creationId xmlns:a16="http://schemas.microsoft.com/office/drawing/2014/main" id="{90C677B5-929F-190C-5B5E-29AD1BF292BB}"/>
+              </a:ext>
+            </a:extLst>
+          </p:cNvPr>
+          <p:cNvCxnSpPr>
+            <a:cxnSpLocks/>
+            <a:stCxn id="495" idx="0"/>
+            <a:endCxn id="437" idx="3"/>
+          </p:cNvCxnSpPr>
+          <p:nvPr/>
+        </p:nvCxnSpPr>
+        <p:spPr>
+          <a:xfrm rot="10800000">
+            <a:off x="6611152" y="5292361"/>
+            <a:ext cx="570746" cy="219"/>
+          </a:xfrm>
+          <a:prstGeom prst="bentConnector3">
+            <a:avLst>
+              <a:gd name="adj1" fmla="val 50000"/>
+            </a:avLst>
+          </a:prstGeom>
+          <a:ln w="12700">
+            <a:solidFill>
+              <a:schemeClr val="tx1"/>
+            </a:solidFill>
+          </a:ln>
+        </p:spPr>
+        <p:style>
+          <a:lnRef idx="1">
+            <a:schemeClr val="accent1"/>
+          </a:lnRef>
+          <a:fillRef idx="0">
+            <a:schemeClr val="accent1"/>
+          </a:fillRef>
+          <a:effectRef idx="0">
+            <a:schemeClr val="accent1"/>
+          </a:effectRef>
+          <a:fontRef idx="minor">
+            <a:schemeClr val="tx1"/>
+          </a:fontRef>
+        </p:style>
+      </p:cxnSp>
+      <p:cxnSp>
+        <p:nvCxnSpPr>
+          <p:cNvPr id="69" name="Elbow Connector 68">
+            <a:extLst>
+              <a:ext uri="{FF2B5EF4-FFF2-40B4-BE49-F238E27FC236}">
+                <a16:creationId xmlns:a16="http://schemas.microsoft.com/office/drawing/2014/main" id="{8DE10120-B5A8-71F9-3165-55438E9AE00C}"/>
+              </a:ext>
+            </a:extLst>
+          </p:cNvPr>
+          <p:cNvCxnSpPr>
+            <a:cxnSpLocks/>
+            <a:stCxn id="495" idx="0"/>
+            <a:endCxn id="435" idx="3"/>
+          </p:cNvCxnSpPr>
+          <p:nvPr/>
+        </p:nvCxnSpPr>
+        <p:spPr>
+          <a:xfrm rot="10800000">
+            <a:off x="6614752" y="5074921"/>
+            <a:ext cx="567146" cy="217659"/>
+          </a:xfrm>
+          <a:prstGeom prst="bentConnector3">
+            <a:avLst>
+              <a:gd name="adj1" fmla="val 50000"/>
+            </a:avLst>
+          </a:prstGeom>
+          <a:ln w="12700">
+            <a:solidFill>
+              <a:schemeClr val="tx1"/>
+            </a:solidFill>
+          </a:ln>
+        </p:spPr>
+        <p:style>
+          <a:lnRef idx="1">
+            <a:schemeClr val="accent1"/>
+          </a:lnRef>
+          <a:fillRef idx="0">
+            <a:schemeClr val="accent1"/>
+          </a:fillRef>
+          <a:effectRef idx="0">
+            <a:schemeClr val="accent1"/>
+          </a:effectRef>
+          <a:fontRef idx="minor">
+            <a:schemeClr val="tx1"/>
+          </a:fontRef>
+        </p:style>
+      </p:cxnSp>
+      <p:cxnSp>
+        <p:nvCxnSpPr>
+          <p:cNvPr id="73" name="Elbow Connector 72">
+            <a:extLst>
+              <a:ext uri="{FF2B5EF4-FFF2-40B4-BE49-F238E27FC236}">
+                <a16:creationId xmlns:a16="http://schemas.microsoft.com/office/drawing/2014/main" id="{9C7A0F97-D766-B5CD-42C3-26AD94A30B5D}"/>
+              </a:ext>
+            </a:extLst>
+          </p:cNvPr>
+          <p:cNvCxnSpPr>
+            <a:cxnSpLocks/>
+            <a:stCxn id="495" idx="0"/>
+          </p:cNvCxnSpPr>
+          <p:nvPr/>
+        </p:nvCxnSpPr>
+        <p:spPr>
+          <a:xfrm rot="10800000" flipV="1">
+            <a:off x="6614752" y="5292578"/>
+            <a:ext cx="567146" cy="173965"/>
+          </a:xfrm>
+          <a:prstGeom prst="bentConnector3">
+            <a:avLst>
+              <a:gd name="adj1" fmla="val 50000"/>
+            </a:avLst>
+          </a:prstGeom>
+          <a:ln w="12700">
+            <a:solidFill>
+              <a:schemeClr val="tx1"/>
+            </a:solidFill>
+          </a:ln>
+        </p:spPr>
+        <p:style>
+          <a:lnRef idx="1">
+            <a:schemeClr val="accent1"/>
+          </a:lnRef>
+          <a:fillRef idx="0">
+            <a:schemeClr val="accent1"/>
+          </a:fillRef>
+          <a:effectRef idx="0">
+            <a:schemeClr val="accent1"/>
+          </a:effectRef>
+          <a:fontRef idx="minor">
+            <a:schemeClr val="tx1"/>
+          </a:fontRef>
+        </p:style>
+      </p:cxnSp>
+      <p:cxnSp>
+        <p:nvCxnSpPr>
+          <p:cNvPr id="80" name="Elbow Connector 79">
+            <a:extLst>
+              <a:ext uri="{FF2B5EF4-FFF2-40B4-BE49-F238E27FC236}">
+                <a16:creationId xmlns:a16="http://schemas.microsoft.com/office/drawing/2014/main" id="{C39D9B4C-580F-9F77-B2DC-47789D8DDD38}"/>
+              </a:ext>
+            </a:extLst>
+          </p:cNvPr>
+          <p:cNvCxnSpPr>
+            <a:cxnSpLocks/>
+            <a:stCxn id="296" idx="4"/>
+            <a:endCxn id="465" idx="3"/>
+          </p:cNvCxnSpPr>
+          <p:nvPr/>
+        </p:nvCxnSpPr>
+        <p:spPr>
+          <a:xfrm flipH="1">
+            <a:off x="6614752" y="6072790"/>
+            <a:ext cx="1020653" cy="2210"/>
+          </a:xfrm>
+          <a:prstGeom prst="straightConnector1">
+            <a:avLst/>
+          </a:prstGeom>
+          <a:ln w="12700">
+            <a:solidFill>
+              <a:schemeClr val="tx1"/>
+            </a:solidFill>
+          </a:ln>
+        </p:spPr>
+        <p:style>
+          <a:lnRef idx="1">
+            <a:schemeClr val="accent1"/>
+          </a:lnRef>
+          <a:fillRef idx="0">
+            <a:schemeClr val="accent1"/>
+          </a:fillRef>
+          <a:effectRef idx="0">
+            <a:schemeClr val="accent1"/>
+          </a:effectRef>
+          <a:fontRef idx="minor">
+            <a:schemeClr val="tx1"/>
+          </a:fontRef>
+        </p:style>
+      </p:cxnSp>
+      <p:cxnSp>
+        <p:nvCxnSpPr>
+          <p:cNvPr id="104" name="Elbow Connector 103">
+            <a:extLst>
+              <a:ext uri="{FF2B5EF4-FFF2-40B4-BE49-F238E27FC236}">
+                <a16:creationId xmlns:a16="http://schemas.microsoft.com/office/drawing/2014/main" id="{3B7EAAFC-E4F3-9AA8-0FCC-EC525DD2D7E8}"/>
+              </a:ext>
+            </a:extLst>
+          </p:cNvPr>
+          <p:cNvCxnSpPr>
+            <a:cxnSpLocks/>
+            <a:endCxn id="296" idx="0"/>
+          </p:cNvCxnSpPr>
+          <p:nvPr/>
+        </p:nvCxnSpPr>
+        <p:spPr>
+          <a:xfrm flipH="1">
+            <a:off x="7707405" y="6072783"/>
+            <a:ext cx="99750" cy="7"/>
+          </a:xfrm>
+          <a:prstGeom prst="straightConnector1">
+            <a:avLst/>
+          </a:prstGeom>
+          <a:ln w="12700">
+            <a:solidFill>
+              <a:schemeClr val="tx1"/>
+            </a:solidFill>
+          </a:ln>
+        </p:spPr>
+        <p:style>
+          <a:lnRef idx="1">
+            <a:schemeClr val="accent1"/>
+          </a:lnRef>
+          <a:fillRef idx="0">
+            <a:schemeClr val="accent1"/>
+          </a:fillRef>
+          <a:effectRef idx="0">
+            <a:schemeClr val="accent1"/>
+          </a:effectRef>
+          <a:fontRef idx="minor">
+            <a:schemeClr val="tx1"/>
+          </a:fontRef>
+        </p:style>
+      </p:cxnSp>
+      <p:cxnSp>
+        <p:nvCxnSpPr>
+          <p:cNvPr id="112" name="Elbow Connector 111">
+            <a:extLst>
+              <a:ext uri="{FF2B5EF4-FFF2-40B4-BE49-F238E27FC236}">
+                <a16:creationId xmlns:a16="http://schemas.microsoft.com/office/drawing/2014/main" id="{1C764552-2426-C21D-B4FD-426D9589B834}"/>
+              </a:ext>
+            </a:extLst>
+          </p:cNvPr>
+          <p:cNvCxnSpPr>
+            <a:cxnSpLocks/>
+          </p:cNvCxnSpPr>
+          <p:nvPr/>
+        </p:nvCxnSpPr>
+        <p:spPr>
+          <a:xfrm rot="16200000" flipV="1">
+            <a:off x="5953609" y="4223074"/>
+            <a:ext cx="3652493" cy="45897"/>
+          </a:xfrm>
+          <a:prstGeom prst="bentConnector3">
+            <a:avLst>
+              <a:gd name="adj1" fmla="val 80511"/>
+            </a:avLst>
+          </a:prstGeom>
+          <a:ln w="12700">
+            <a:solidFill>
+              <a:schemeClr val="tx1"/>
+            </a:solidFill>
+          </a:ln>
+        </p:spPr>
+        <p:style>
+          <a:lnRef idx="1">
+            <a:schemeClr val="accent1"/>
+          </a:lnRef>
+          <a:fillRef idx="0">
+            <a:schemeClr val="accent1"/>
+          </a:fillRef>
+          <a:effectRef idx="0">
+            <a:schemeClr val="accent1"/>
+          </a:effectRef>
+          <a:fontRef idx="minor">
+            <a:schemeClr val="tx1"/>
+          </a:fontRef>
+        </p:style>
+      </p:cxnSp>
     </p:spTree>
     <p:extLst>
       <p:ext uri="{BB962C8B-B14F-4D97-AF65-F5344CB8AC3E}">
@@ -18777,4 +19249,10 @@
     </a:ext>
   </a:extLst>
 </a:theme>
+</file>
+
+<file path=docMetadata/LabelInfo.xml><?xml version="1.0" encoding="utf-8"?>
+<clbl:labelList xmlns:clbl="http://schemas.microsoft.com/office/2020/mipLabelMetadata">
+  <clbl:label id="{0cf7ac0a-4681-4823-ab0b-04ef02c5f873}" enabled="1" method="Standard" siteId="{42f7676c-f455-423c-82f6-dc2d99791af7}" contentBits="0" removed="0"/>
+</clbl:labelList>
 </file>
</xml_diff>